<commit_message>
Deck slide 7 and STATUS: the extension as built and measured
Slide 7 said the extension was 'being built' on a branch and planned a demo
(washer photo, mid-answer interruption) that does not work yet. It now states
what is built, the held-out real-camera result (5/9 correct, 0 wrong), what is
unproven, and a demo plan that matches. STATUS.md: PR and photo items updated.

Co-Authored-By: Claude Opus 5.5 <noreply@anthropic.com>
</commit_message>
<xml_diff>
--- a/deck/ThaparPatiala_TEAM_FDBv3_ppt.pptx
+++ b/deck/ThaparPatiala_TEAM_FDBv3_ppt.pptx
@@ -5063,7 +5063,7 @@
                 <a:ea typeface="Cambria" pitchFamily="34" charset="-122"/>
                 <a:cs typeface="Cambria" pitchFamily="34" charset="-120"/>
               </a:rPr>
-              <a:t>Extension: troubleshooting from a camera frame</a:t>
+              <a:t>Extension: troubleshooting through the camera</a:t>
             </a:r>
             <a:endParaRPr lang="en-US" sz="3000" dirty="0"/>
           </a:p>
@@ -5094,7 +5094,7 @@
               <a:buNone/>
             </a:pPr>
             <a:r>
-              <a:rPr lang="en-US" sz="1700" dirty="0">
+              <a:rPr lang="en-US" sz="1500" dirty="0">
                 <a:solidFill>
                   <a:srgbClr val="1F2328"/>
                 </a:solidFill>
@@ -5102,16 +5102,16 @@
                 <a:ea typeface="Calibri" pitchFamily="34" charset="-122"/>
                 <a:cs typeface="Calibri" pitchFamily="34" charset="-120"/>
               </a:rPr>
-              <a:t>The user shows the agent an appliance panel or a router’s LEDs; the agent reads the error code or LED pattern and looks it up.</a:t>
-            </a:r>
-            <a:endParaRPr lang="en-US" sz="1700" dirty="0"/>
-          </a:p>
-          <a:p>
-            <a:pPr indent="0" marL="0">
-              <a:buNone/>
-            </a:pPr>
-            <a:r>
-              <a:rPr lang="en-US" sz="1700" dirty="0">
+              <a:t>A separate live LiveKit agent (fdb/agent_extension.py): the user points their phone camera at a TV, router or washer and asks what's wrong. One tool reads the latest frame: error code, LED colour, or on-screen text.</a:t>
+            </a:r>
+            <a:endParaRPr lang="en-US" sz="1500" dirty="0"/>
+          </a:p>
+          <a:p>
+            <a:pPr indent="0" marL="0">
+              <a:buNone/>
+            </a:pPr>
+            <a:r>
+              <a:rPr lang="en-US" sz="1500" dirty="0">
                 <a:solidFill>
                   <a:srgbClr val="1F2328"/>
                 </a:solidFill>
@@ -5121,14 +5121,14 @@
               </a:rPr>
               <a:t> </a:t>
             </a:r>
-            <a:endParaRPr lang="en-US" sz="1700" dirty="0"/>
-          </a:p>
-          <a:p>
-            <a:pPr indent="0" marL="0">
-              <a:buNone/>
-            </a:pPr>
-            <a:r>
-              <a:rPr lang="en-US" sz="1700" dirty="0">
+            <a:endParaRPr lang="en-US" sz="1500" dirty="0"/>
+          </a:p>
+          <a:p>
+            <a:pPr indent="0" marL="0">
+              <a:buNone/>
+            </a:pPr>
+            <a:r>
+              <a:rPr lang="en-US" sz="1500" dirty="0">
                 <a:solidFill>
                   <a:srgbClr val="1F2328"/>
                 </a:solidFill>
@@ -5136,16 +5136,16 @@
                 <a:ea typeface="Calibri" pitchFamily="34" charset="-122"/>
                 <a:cs typeface="Calibri" pitchFamily="34" charset="-120"/>
               </a:rPr>
-              <a:t>When the frame can't be decided (blur, two plausible LEDs), it asks instead of guessing, and nothing is dispatched until the user answers.</a:t>
-            </a:r>
-            <a:endParaRPr lang="en-US" sz="1700" dirty="0"/>
-          </a:p>
-          <a:p>
-            <a:pPr indent="0" marL="0">
-              <a:buNone/>
-            </a:pPr>
-            <a:r>
-              <a:rPr lang="en-US" sz="1700" dirty="0">
+              <a:t>Three outcomes only: a diagnosis with the manual's steps, a question naming both candidates, or a request for a better shot. It asks rather than guesses.</a:t>
+            </a:r>
+            <a:endParaRPr lang="en-US" sz="1500" dirty="0"/>
+          </a:p>
+          <a:p>
+            <a:pPr indent="0" marL="0">
+              <a:buNone/>
+            </a:pPr>
+            <a:r>
+              <a:rPr lang="en-US" sz="1500" dirty="0">
                 <a:solidFill>
                   <a:srgbClr val="1F2328"/>
                 </a:solidFill>
@@ -5155,14 +5155,14 @@
               </a:rPr>
               <a:t> </a:t>
             </a:r>
-            <a:endParaRPr lang="en-US" sz="1700" dirty="0"/>
-          </a:p>
-          <a:p>
-            <a:pPr indent="0" marL="0">
-              <a:buNone/>
-            </a:pPr>
-            <a:r>
-              <a:rPr lang="en-US" sz="1700" b="1" dirty="0">
+            <a:endParaRPr lang="en-US" sz="1500" dirty="0"/>
+          </a:p>
+          <a:p>
+            <a:pPr indent="0" marL="0">
+              <a:buNone/>
+            </a:pPr>
+            <a:r>
+              <a:rPr lang="en-US" sz="1500" b="1" dirty="0">
                 <a:solidFill>
                   <a:srgbClr val="1F2328"/>
                 </a:solidFill>
@@ -5170,9 +5170,9 @@
                 <a:ea typeface="Calibri" pitchFamily="34" charset="-122"/>
                 <a:cs typeface="Calibri" pitchFamily="34" charset="-120"/>
               </a:rPr>
-              <a:t>Being built by a teammate on branch extension-camera, on top of the perception code in parley/multimodal/. It is not part of the FDB-v3 scores.</a:t>
-            </a:r>
-            <a:endParaRPr lang="en-US" sz="1700" dirty="0"/>
+              <a:t>Real phone frames, held out: 5/9 diagnosed (every real 'No Signal' TV), 4 abstained, 0 wrong. The colour model was trained on synthetic frames only; routers and washers on camera are not yet proven. Not part of the FDB-v3 scores.</a:t>
+            </a:r>
+            <a:endParaRPr lang="en-US" sz="1500" dirty="0"/>
           </a:p>
         </p:txBody>
       </p:sp>
@@ -5270,7 +5270,7 @@
                 <a:ea typeface="Calibri" pitchFamily="34" charset="-122"/>
                 <a:cs typeface="Calibri" pitchFamily="34" charset="-120"/>
               </a:rPr>
-              <a:t>1. Photo of a washing-machine panel → error code read → fix looked up</a:t>
+              <a:t>1. Camera away from the device → it asks to see it, no guess</a:t>
             </a:r>
             <a:endParaRPr lang="en-US" sz="1400" dirty="0"/>
           </a:p>
@@ -5287,7 +5287,7 @@
                 <a:ea typeface="Calibri" pitchFamily="34" charset="-122"/>
                 <a:cs typeface="Calibri" pitchFamily="34" charset="-120"/>
               </a:rPr>
-              <a:t>2. Router with two LEDs lit → “the WAN LED or the power LED?”</a:t>
+              <a:t>2. A real TV showing 'No Signal' → diagnosed from the screen text, fix read out</a:t>
             </a:r>
             <a:endParaRPr lang="en-US" sz="1400" dirty="0"/>
           </a:p>
@@ -5304,7 +5304,7 @@
                 <a:ea typeface="Calibri" pitchFamily="34" charset="-122"/>
                 <a:cs typeface="Calibri" pitchFamily="34" charset="-120"/>
               </a:rPr>
-              <a:t>3. The user interrupts mid-answer; the plan updates</a:t>
+              <a:t>3. Groq's free voice quota runs out → offline Piper voice takes over, no drop</a:t>
             </a:r>
             <a:endParaRPr lang="en-US" sz="1400" dirty="0"/>
           </a:p>

</xml_diff>